<commit_message>
Update PPT: reflect wttr.in API switch (KMA removed)
- Slide 1: feature tag '기상청날씨'→'wttr.in날씨', footer URL updated
- Slide 2: internet services box: apihub.kma.go.kr → wttr.in
- Slide 3: feature #4/#5 descriptions updated for wttr.in
- Slide 6: tasks fetchTempKMA/fetchCondKMA → fetchWeatherWttr/fetchHolidays
- Slide 7: full redesign — KMA flow → wttr.in text format flow,
  WMO ww code table → descToCondition keyword mapping table

Co-Authored-By: Claude Sonnet 4.6 <noreply@anthropic.com>
</commit_message>
<xml_diff>
--- a/IoT_WallClock_설명.pptx
+++ b/IoT_WallClock_설명.pptx
@@ -1704,7 +1704,7 @@
                   <a:srgbClr val="000000"/>
                 </a:solidFill>
               </a:rPr>
-              <a:t>기상청날씨</a:t>
+              <a:t>wttr.in날씨</a:t>
             </a:r>
             <a:endParaRPr lang="en-US" sz="1200" dirty="0"/>
           </a:p>
@@ -1862,7 +1862,7 @@
                   <a:srgbClr val="CCCCCC"/>
                 </a:solidFill>
               </a:rPr>
-              <a:t>Arduino .ino  ·  WiFiManager  ·  ESP8266WiFiMulti  ·  apihub.kma.go.kr  ·  NTP  ·  DHT11  ·  CDS  ·  date.nager.at</a:t>
+              <a:t>Arduino .ino  ·  WiFiManager  ·  ESP8266WiFiMulti  ·  wttr.in  ·  NTP  ·  DHT11  ·  CDS  ·  date.nager.at</a:t>
             </a:r>
             <a:endParaRPr lang="en-US" sz="1100" dirty="0"/>
           </a:p>
@@ -2615,7 +2615,7 @@
                   <a:srgbClr val="000000"/>
                 </a:solidFill>
               </a:rPr>
-              <a:t>apihub.kma.go.kr</a:t>
+              <a:t>wttr.in</a:t>
             </a:r>
             <a:endParaRPr lang="en-US" sz="1200" dirty="0"/>
           </a:p>
@@ -3573,7 +3573,7 @@
                   <a:srgbClr val="000000"/>
                 </a:solidFill>
               </a:rPr>
-              <a:t>기상청 동네 날씨 수신</a:t>
+              <a:t>외부 날씨 수신 (wttr.in HTTPS)</a:t>
             </a:r>
             <a:endParaRPr lang="en-US" sz="1300" dirty="0"/>
           </a:p>
@@ -3609,7 +3609,7 @@
                   <a:srgbClr val="666666"/>
                 </a:solidFill>
               </a:rPr>
-              <a:t>apihub.kma.go.kr 지상관측 API</a:t>
+              <a:t>fetchWeatherWttr() — 실패시 60초/성공시 5분</a:t>
             </a:r>
             <a:endParaRPr lang="en-US" sz="1050" dirty="0"/>
           </a:p>
@@ -3623,7 +3623,7 @@
                   <a:srgbClr val="666666"/>
                 </a:solidFill>
               </a:rPr>
-              <a:t>기온(ta)·습도(hm)·현천코드(ww) 1분 갱신</a:t>
+              <a:t>텍스트 포맷 (%t|%C) → 기온+날씨조건</a:t>
             </a:r>
             <a:endParaRPr lang="en-US" sz="1050" dirty="0"/>
           </a:p>
@@ -3781,7 +3781,7 @@
                   <a:srgbClr val="666666"/>
                 </a:solidFill>
               </a:rPr>
-              <a:t>온도: 기상청 지상관측 (외부 기온)</a:t>
+              <a:t>온도: wttr.in 외부 기온 (1~5분 갱신)</a:t>
             </a:r>
             <a:endParaRPr lang="en-US" sz="1050" dirty="0"/>
           </a:p>
@@ -6699,7 +6699,7 @@
         </p:nvSpPr>
         <p:spPr>
           <a:xfrm>
-            <a:off x="1097280" y="1691640"/>
+            <a:off x="845820" y="1691640"/>
             <a:ext cx="0" cy="365760"/>
           </a:xfrm>
           <a:prstGeom prst="line">
@@ -6722,8 +6722,8 @@
         </p:nvSpPr>
         <p:spPr>
           <a:xfrm>
-            <a:off x="274320" y="2057400"/>
-            <a:ext cx="1645920" cy="1005840"/>
+            <a:off x="182880" y="2057400"/>
+            <a:ext cx="1325880" cy="1005840"/>
           </a:xfrm>
           <a:prstGeom prst="rect">
             <a:avLst/>
@@ -6747,31 +6747,31 @@
         </p:nvSpPr>
         <p:spPr>
           <a:xfrm>
-            <a:off x="320040" y="2084832"/>
-            <a:ext cx="1554480" cy="411480"/>
-          </a:xfrm>
-          <a:prstGeom prst="rect">
-            <a:avLst/>
-          </a:prstGeom>
-          <a:noFill/>
-          <a:ln/>
-        </p:spPr>
-        <p:txBody>
-          <a:bodyPr wrap="square" rtlCol="0" anchor="ctr"/>
-          <a:lstStyle/>
-          <a:p>
-            <a:pPr algn="ctr" indent="0" marL="0">
-              <a:buNone/>
-            </a:pPr>
-            <a:r>
-              <a:rPr lang="en-US" sz="900" b="1" dirty="0">
+            <a:off x="219456" y="2084832"/>
+            <a:ext cx="1252728" cy="411480"/>
+          </a:xfrm>
+          <a:prstGeom prst="rect">
+            <a:avLst/>
+          </a:prstGeom>
+          <a:noFill/>
+          <a:ln/>
+        </p:spPr>
+        <p:txBody>
+          <a:bodyPr wrap="square" rtlCol="0" anchor="ctr"/>
+          <a:lstStyle/>
+          <a:p>
+            <a:pPr algn="ctr" indent="0" marL="0">
+              <a:buNone/>
+            </a:pPr>
+            <a:r>
+              <a:rPr lang="en-US" sz="850" b="1" dirty="0">
                 <a:solidFill>
                   <a:srgbClr val="000000"/>
                 </a:solidFill>
               </a:rPr>
               <a:t>drawFrame()</a:t>
             </a:r>
-            <a:endParaRPr lang="en-US" sz="900" dirty="0"/>
+            <a:endParaRPr lang="en-US" sz="850" dirty="0"/>
           </a:p>
         </p:txBody>
       </p:sp>
@@ -6783,45 +6783,45 @@
         </p:nvSpPr>
         <p:spPr>
           <a:xfrm>
-            <a:off x="320040" y="2496312"/>
-            <a:ext cx="1554480" cy="548640"/>
-          </a:xfrm>
-          <a:prstGeom prst="rect">
-            <a:avLst/>
-          </a:prstGeom>
-          <a:noFill/>
-          <a:ln/>
-        </p:spPr>
-        <p:txBody>
-          <a:bodyPr wrap="square" rtlCol="0" anchor="ctr"/>
-          <a:lstStyle/>
-          <a:p>
-            <a:pPr algn="ctr" indent="0" marL="0">
-              <a:buNone/>
-            </a:pPr>
-            <a:r>
-              <a:rPr lang="en-US" sz="1000" dirty="0">
+            <a:off x="219456" y="2496312"/>
+            <a:ext cx="1252728" cy="548640"/>
+          </a:xfrm>
+          <a:prstGeom prst="rect">
+            <a:avLst/>
+          </a:prstGeom>
+          <a:noFill/>
+          <a:ln/>
+        </p:spPr>
+        <p:txBody>
+          <a:bodyPr wrap="square" rtlCol="0" anchor="ctr"/>
+          <a:lstStyle/>
+          <a:p>
+            <a:pPr algn="ctr" indent="0" marL="0">
+              <a:buNone/>
+            </a:pPr>
+            <a:r>
+              <a:rPr lang="en-US" sz="950" dirty="0">
                 <a:solidFill>
                   <a:srgbClr val="666666"/>
                 </a:solidFill>
               </a:rPr>
               <a:t>50 ms</a:t>
             </a:r>
-            <a:endParaRPr lang="en-US" sz="1000" dirty="0"/>
-          </a:p>
-          <a:p>
-            <a:pPr algn="ctr" indent="0" marL="0">
-              <a:buNone/>
-            </a:pPr>
-            <a:r>
-              <a:rPr lang="en-US" sz="1000" dirty="0">
+            <a:endParaRPr lang="en-US" sz="950" dirty="0"/>
+          </a:p>
+          <a:p>
+            <a:pPr algn="ctr" indent="0" marL="0">
+              <a:buNone/>
+            </a:pPr>
+            <a:r>
+              <a:rPr lang="en-US" sz="950" dirty="0">
                 <a:solidFill>
                   <a:srgbClr val="666666"/>
                 </a:solidFill>
               </a:rPr>
               <a:t>화면 갱신 (20fps)</a:t>
             </a:r>
-            <a:endParaRPr lang="en-US" sz="1000" dirty="0"/>
+            <a:endParaRPr lang="en-US" sz="950" dirty="0"/>
           </a:p>
         </p:txBody>
       </p:sp>
@@ -6833,7 +6833,7 @@
         </p:nvSpPr>
         <p:spPr>
           <a:xfrm>
-            <a:off x="2834640" y="1691640"/>
+            <a:off x="2354580" y="1691640"/>
             <a:ext cx="0" cy="365760"/>
           </a:xfrm>
           <a:prstGeom prst="line">
@@ -6856,8 +6856,8 @@
         </p:nvSpPr>
         <p:spPr>
           <a:xfrm>
-            <a:off x="2011680" y="2057400"/>
-            <a:ext cx="1645920" cy="1005840"/>
+            <a:off x="1691640" y="2057400"/>
+            <a:ext cx="1325880" cy="1005840"/>
           </a:xfrm>
           <a:prstGeom prst="rect">
             <a:avLst/>
@@ -6881,31 +6881,31 @@
         </p:nvSpPr>
         <p:spPr>
           <a:xfrm>
-            <a:off x="2057400" y="2084832"/>
-            <a:ext cx="1554480" cy="411480"/>
-          </a:xfrm>
-          <a:prstGeom prst="rect">
-            <a:avLst/>
-          </a:prstGeom>
-          <a:noFill/>
-          <a:ln/>
-        </p:spPr>
-        <p:txBody>
-          <a:bodyPr wrap="square" rtlCol="0" anchor="ctr"/>
-          <a:lstStyle/>
-          <a:p>
-            <a:pPr algn="ctr" indent="0" marL="0">
-              <a:buNone/>
-            </a:pPr>
-            <a:r>
-              <a:rPr lang="en-US" sz="900" b="1" dirty="0">
+            <a:off x="1728216" y="2084832"/>
+            <a:ext cx="1252728" cy="411480"/>
+          </a:xfrm>
+          <a:prstGeom prst="rect">
+            <a:avLst/>
+          </a:prstGeom>
+          <a:noFill/>
+          <a:ln/>
+        </p:spPr>
+        <p:txBody>
+          <a:bodyPr wrap="square" rtlCol="0" anchor="ctr"/>
+          <a:lstStyle/>
+          <a:p>
+            <a:pPr algn="ctr" indent="0" marL="0">
+              <a:buNone/>
+            </a:pPr>
+            <a:r>
+              <a:rPr lang="en-US" sz="850" b="1" dirty="0">
                 <a:solidFill>
                   <a:srgbClr val="000000"/>
                 </a:solidFill>
               </a:rPr>
               <a:t>readDHT()</a:t>
             </a:r>
-            <a:endParaRPr lang="en-US" sz="900" dirty="0"/>
+            <a:endParaRPr lang="en-US" sz="850" dirty="0"/>
           </a:p>
         </p:txBody>
       </p:sp>
@@ -6917,45 +6917,45 @@
         </p:nvSpPr>
         <p:spPr>
           <a:xfrm>
-            <a:off x="2057400" y="2496312"/>
-            <a:ext cx="1554480" cy="548640"/>
-          </a:xfrm>
-          <a:prstGeom prst="rect">
-            <a:avLst/>
-          </a:prstGeom>
-          <a:noFill/>
-          <a:ln/>
-        </p:spPr>
-        <p:txBody>
-          <a:bodyPr wrap="square" rtlCol="0" anchor="ctr"/>
-          <a:lstStyle/>
-          <a:p>
-            <a:pPr algn="ctr" indent="0" marL="0">
-              <a:buNone/>
-            </a:pPr>
-            <a:r>
-              <a:rPr lang="en-US" sz="1000" dirty="0">
+            <a:off x="1728216" y="2496312"/>
+            <a:ext cx="1252728" cy="548640"/>
+          </a:xfrm>
+          <a:prstGeom prst="rect">
+            <a:avLst/>
+          </a:prstGeom>
+          <a:noFill/>
+          <a:ln/>
+        </p:spPr>
+        <p:txBody>
+          <a:bodyPr wrap="square" rtlCol="0" anchor="ctr"/>
+          <a:lstStyle/>
+          <a:p>
+            <a:pPr algn="ctr" indent="0" marL="0">
+              <a:buNone/>
+            </a:pPr>
+            <a:r>
+              <a:rPr lang="en-US" sz="950" dirty="0">
                 <a:solidFill>
                   <a:srgbClr val="666666"/>
                 </a:solidFill>
               </a:rPr>
               <a:t>2.5 s</a:t>
             </a:r>
-            <a:endParaRPr lang="en-US" sz="1000" dirty="0"/>
-          </a:p>
-          <a:p>
-            <a:pPr algn="ctr" indent="0" marL="0">
-              <a:buNone/>
-            </a:pPr>
-            <a:r>
-              <a:rPr lang="en-US" sz="1000" dirty="0">
+            <a:endParaRPr lang="en-US" sz="950" dirty="0"/>
+          </a:p>
+          <a:p>
+            <a:pPr algn="ctr" indent="0" marL="0">
+              <a:buNone/>
+            </a:pPr>
+            <a:r>
+              <a:rPr lang="en-US" sz="950" dirty="0">
                 <a:solidFill>
                   <a:srgbClr val="666666"/>
                 </a:solidFill>
               </a:rPr>
               <a:t>실내 습도</a:t>
             </a:r>
-            <a:endParaRPr lang="en-US" sz="1000" dirty="0"/>
+            <a:endParaRPr lang="en-US" sz="950" dirty="0"/>
           </a:p>
         </p:txBody>
       </p:sp>
@@ -6967,7 +6967,7 @@
         </p:nvSpPr>
         <p:spPr>
           <a:xfrm>
-            <a:off x="4480560" y="1691640"/>
+            <a:off x="3863340" y="1691640"/>
             <a:ext cx="0" cy="365760"/>
           </a:xfrm>
           <a:prstGeom prst="line">
@@ -6990,8 +6990,8 @@
         </p:nvSpPr>
         <p:spPr>
           <a:xfrm>
-            <a:off x="3657600" y="2057400"/>
-            <a:ext cx="1645920" cy="1005840"/>
+            <a:off x="3200400" y="2057400"/>
+            <a:ext cx="1325880" cy="1005840"/>
           </a:xfrm>
           <a:prstGeom prst="rect">
             <a:avLst/>
@@ -7015,31 +7015,31 @@
         </p:nvSpPr>
         <p:spPr>
           <a:xfrm>
-            <a:off x="3703320" y="2084832"/>
-            <a:ext cx="1554480" cy="411480"/>
-          </a:xfrm>
-          <a:prstGeom prst="rect">
-            <a:avLst/>
-          </a:prstGeom>
-          <a:noFill/>
-          <a:ln/>
-        </p:spPr>
-        <p:txBody>
-          <a:bodyPr wrap="square" rtlCol="0" anchor="ctr"/>
-          <a:lstStyle/>
-          <a:p>
-            <a:pPr algn="ctr" indent="0" marL="0">
-              <a:buNone/>
-            </a:pPr>
-            <a:r>
-              <a:rPr lang="en-US" sz="900" b="1" dirty="0">
+            <a:off x="3236976" y="2084832"/>
+            <a:ext cx="1252728" cy="411480"/>
+          </a:xfrm>
+          <a:prstGeom prst="rect">
+            <a:avLst/>
+          </a:prstGeom>
+          <a:noFill/>
+          <a:ln/>
+        </p:spPr>
+        <p:txBody>
+          <a:bodyPr wrap="square" rtlCol="0" anchor="ctr"/>
+          <a:lstStyle/>
+          <a:p>
+            <a:pPr algn="ctr" indent="0" marL="0">
+              <a:buNone/>
+            </a:pPr>
+            <a:r>
+              <a:rPr lang="en-US" sz="850" b="1" dirty="0">
                 <a:solidFill>
                   <a:srgbClr val="000000"/>
                 </a:solidFill>
               </a:rPr>
               <a:t>updateBrightness()</a:t>
             </a:r>
-            <a:endParaRPr lang="en-US" sz="900" dirty="0"/>
+            <a:endParaRPr lang="en-US" sz="850" dirty="0"/>
           </a:p>
         </p:txBody>
       </p:sp>
@@ -7051,45 +7051,45 @@
         </p:nvSpPr>
         <p:spPr>
           <a:xfrm>
-            <a:off x="3703320" y="2496312"/>
-            <a:ext cx="1554480" cy="548640"/>
-          </a:xfrm>
-          <a:prstGeom prst="rect">
-            <a:avLst/>
-          </a:prstGeom>
-          <a:noFill/>
-          <a:ln/>
-        </p:spPr>
-        <p:txBody>
-          <a:bodyPr wrap="square" rtlCol="0" anchor="ctr"/>
-          <a:lstStyle/>
-          <a:p>
-            <a:pPr algn="ctr" indent="0" marL="0">
-              <a:buNone/>
-            </a:pPr>
-            <a:r>
-              <a:rPr lang="en-US" sz="1000" dirty="0">
+            <a:off x="3236976" y="2496312"/>
+            <a:ext cx="1252728" cy="548640"/>
+          </a:xfrm>
+          <a:prstGeom prst="rect">
+            <a:avLst/>
+          </a:prstGeom>
+          <a:noFill/>
+          <a:ln/>
+        </p:spPr>
+        <p:txBody>
+          <a:bodyPr wrap="square" rtlCol="0" anchor="ctr"/>
+          <a:lstStyle/>
+          <a:p>
+            <a:pPr algn="ctr" indent="0" marL="0">
+              <a:buNone/>
+            </a:pPr>
+            <a:r>
+              <a:rPr lang="en-US" sz="950" dirty="0">
                 <a:solidFill>
                   <a:srgbClr val="666666"/>
                 </a:solidFill>
               </a:rPr>
               <a:t>500 ms</a:t>
             </a:r>
-            <a:endParaRPr lang="en-US" sz="1000" dirty="0"/>
-          </a:p>
-          <a:p>
-            <a:pPr algn="ctr" indent="0" marL="0">
-              <a:buNone/>
-            </a:pPr>
-            <a:r>
-              <a:rPr lang="en-US" sz="1000" dirty="0">
+            <a:endParaRPr lang="en-US" sz="950" dirty="0"/>
+          </a:p>
+          <a:p>
+            <a:pPr algn="ctr" indent="0" marL="0">
+              <a:buNone/>
+            </a:pPr>
+            <a:r>
+              <a:rPr lang="en-US" sz="950" dirty="0">
                 <a:solidFill>
                   <a:srgbClr val="666666"/>
                 </a:solidFill>
               </a:rPr>
               <a:t>CDS 비례밝기</a:t>
             </a:r>
-            <a:endParaRPr lang="en-US" sz="1000" dirty="0"/>
+            <a:endParaRPr lang="en-US" sz="950" dirty="0"/>
           </a:p>
         </p:txBody>
       </p:sp>
@@ -7101,7 +7101,7 @@
         </p:nvSpPr>
         <p:spPr>
           <a:xfrm>
-            <a:off x="6309360" y="1691640"/>
+            <a:off x="5372100" y="1691640"/>
             <a:ext cx="0" cy="365760"/>
           </a:xfrm>
           <a:prstGeom prst="line">
@@ -7124,8 +7124,8 @@
         </p:nvSpPr>
         <p:spPr>
           <a:xfrm>
-            <a:off x="5486400" y="2057400"/>
-            <a:ext cx="1645920" cy="1005840"/>
+            <a:off x="4709160" y="2057400"/>
+            <a:ext cx="1325880" cy="1005840"/>
           </a:xfrm>
           <a:prstGeom prst="rect">
             <a:avLst/>
@@ -7149,31 +7149,31 @@
         </p:nvSpPr>
         <p:spPr>
           <a:xfrm>
-            <a:off x="5532120" y="2084832"/>
-            <a:ext cx="1554480" cy="411480"/>
-          </a:xfrm>
-          <a:prstGeom prst="rect">
-            <a:avLst/>
-          </a:prstGeom>
-          <a:noFill/>
-          <a:ln/>
-        </p:spPr>
-        <p:txBody>
-          <a:bodyPr wrap="square" rtlCol="0" anchor="ctr"/>
-          <a:lstStyle/>
-          <a:p>
-            <a:pPr algn="ctr" indent="0" marL="0">
-              <a:buNone/>
-            </a:pPr>
-            <a:r>
-              <a:rPr lang="en-US" sz="900" b="1" dirty="0">
+            <a:off x="4745736" y="2084832"/>
+            <a:ext cx="1252728" cy="411480"/>
+          </a:xfrm>
+          <a:prstGeom prst="rect">
+            <a:avLst/>
+          </a:prstGeom>
+          <a:noFill/>
+          <a:ln/>
+        </p:spPr>
+        <p:txBody>
+          <a:bodyPr wrap="square" rtlCol="0" anchor="ctr"/>
+          <a:lstStyle/>
+          <a:p>
+            <a:pPr algn="ctr" indent="0" marL="0">
+              <a:buNone/>
+            </a:pPr>
+            <a:r>
+              <a:rPr lang="en-US" sz="850" b="1" dirty="0">
                 <a:solidFill>
                   <a:srgbClr val="000000"/>
                 </a:solidFill>
               </a:rPr>
-              <a:t>fetchWeatherKMA()</a:t>
-            </a:r>
-            <a:endParaRPr lang="en-US" sz="900" dirty="0"/>
+              <a:t>fetchWeatherWttr()</a:t>
+            </a:r>
+            <a:endParaRPr lang="en-US" sz="850" dirty="0"/>
           </a:p>
         </p:txBody>
       </p:sp>
@@ -7185,45 +7185,45 @@
         </p:nvSpPr>
         <p:spPr>
           <a:xfrm>
-            <a:off x="5532120" y="2496312"/>
-            <a:ext cx="1554480" cy="548640"/>
-          </a:xfrm>
-          <a:prstGeom prst="rect">
-            <a:avLst/>
-          </a:prstGeom>
-          <a:noFill/>
-          <a:ln/>
-        </p:spPr>
-        <p:txBody>
-          <a:bodyPr wrap="square" rtlCol="0" anchor="ctr"/>
-          <a:lstStyle/>
-          <a:p>
-            <a:pPr algn="ctr" indent="0" marL="0">
-              <a:buNone/>
-            </a:pPr>
-            <a:r>
-              <a:rPr lang="en-US" sz="1000" dirty="0">
+            <a:off x="4745736" y="2496312"/>
+            <a:ext cx="1252728" cy="548640"/>
+          </a:xfrm>
+          <a:prstGeom prst="rect">
+            <a:avLst/>
+          </a:prstGeom>
+          <a:noFill/>
+          <a:ln/>
+        </p:spPr>
+        <p:txBody>
+          <a:bodyPr wrap="square" rtlCol="0" anchor="ctr"/>
+          <a:lstStyle/>
+          <a:p>
+            <a:pPr algn="ctr" indent="0" marL="0">
+              <a:buNone/>
+            </a:pPr>
+            <a:r>
+              <a:rPr lang="en-US" sz="950" dirty="0">
                 <a:solidFill>
                   <a:srgbClr val="666666"/>
                 </a:solidFill>
               </a:rPr>
-              <a:t>1 분</a:t>
-            </a:r>
-            <a:endParaRPr lang="en-US" sz="1000" dirty="0"/>
-          </a:p>
-          <a:p>
-            <a:pPr algn="ctr" indent="0" marL="0">
-              <a:buNone/>
-            </a:pPr>
-            <a:r>
-              <a:rPr lang="en-US" sz="1000" dirty="0">
+              <a:t>1~5 분</a:t>
+            </a:r>
+            <a:endParaRPr lang="en-US" sz="950" dirty="0"/>
+          </a:p>
+          <a:p>
+            <a:pPr algn="ctr" indent="0" marL="0">
+              <a:buNone/>
+            </a:pPr>
+            <a:r>
+              <a:rPr lang="en-US" sz="950" dirty="0">
                 <a:solidFill>
                   <a:srgbClr val="666666"/>
                 </a:solidFill>
               </a:rPr>
-              <a:t>기상청 날씨</a:t>
-            </a:r>
-            <a:endParaRPr lang="en-US" sz="1000" dirty="0"/>
+              <a:t>기온+날씨</a:t>
+            </a:r>
+            <a:endParaRPr lang="en-US" sz="950" dirty="0"/>
           </a:p>
         </p:txBody>
       </p:sp>
@@ -7235,7 +7235,7 @@
         </p:nvSpPr>
         <p:spPr>
           <a:xfrm>
-            <a:off x="8229600" y="1691640"/>
+            <a:off x="6880860" y="1691640"/>
             <a:ext cx="0" cy="365760"/>
           </a:xfrm>
           <a:prstGeom prst="line">
@@ -7258,8 +7258,8 @@
         </p:nvSpPr>
         <p:spPr>
           <a:xfrm>
-            <a:off x="7406640" y="2057400"/>
-            <a:ext cx="1645920" cy="1005840"/>
+            <a:off x="6217920" y="2057400"/>
+            <a:ext cx="1325880" cy="1005840"/>
           </a:xfrm>
           <a:prstGeom prst="rect">
             <a:avLst/>
@@ -7283,108 +7283,364 @@
         </p:nvSpPr>
         <p:spPr>
           <a:xfrm>
-            <a:off x="7452360" y="2084832"/>
-            <a:ext cx="1554480" cy="411480"/>
-          </a:xfrm>
-          <a:prstGeom prst="rect">
-            <a:avLst/>
-          </a:prstGeom>
-          <a:noFill/>
-          <a:ln/>
-        </p:spPr>
-        <p:txBody>
-          <a:bodyPr wrap="square" rtlCol="0" anchor="ctr"/>
-          <a:lstStyle/>
-          <a:p>
-            <a:pPr algn="ctr" indent="0" marL="0">
-              <a:buNone/>
-            </a:pPr>
-            <a:r>
-              <a:rPr lang="en-US" sz="900" b="1" dirty="0">
+            <a:off x="6254496" y="2084832"/>
+            <a:ext cx="1252728" cy="411480"/>
+          </a:xfrm>
+          <a:prstGeom prst="rect">
+            <a:avLst/>
+          </a:prstGeom>
+          <a:noFill/>
+          <a:ln/>
+        </p:spPr>
+        <p:txBody>
+          <a:bodyPr wrap="square" rtlCol="0" anchor="ctr"/>
+          <a:lstStyle/>
+          <a:p>
+            <a:pPr algn="ctr" indent="0" marL="0">
+              <a:buNone/>
+            </a:pPr>
+            <a:r>
+              <a:rPr lang="en-US" sz="850" b="1" dirty="0">
                 <a:solidFill>
                   <a:srgbClr val="000000"/>
                 </a:solidFill>
               </a:rPr>
+              <a:t>fetchHolidays()</a:t>
+            </a:r>
+            <a:endParaRPr lang="en-US" sz="850" dirty="0"/>
+          </a:p>
+        </p:txBody>
+      </p:sp>
+      <p:sp>
+        <p:nvSpPr>
+          <p:cNvPr id="26" name="Text 24"/>
+          <p:cNvSpPr/>
+          <p:nvPr/>
+        </p:nvSpPr>
+        <p:spPr>
+          <a:xfrm>
+            <a:off x="6254496" y="2496312"/>
+            <a:ext cx="1252728" cy="548640"/>
+          </a:xfrm>
+          <a:prstGeom prst="rect">
+            <a:avLst/>
+          </a:prstGeom>
+          <a:noFill/>
+          <a:ln/>
+        </p:spPr>
+        <p:txBody>
+          <a:bodyPr wrap="square" rtlCol="0" anchor="ctr"/>
+          <a:lstStyle/>
+          <a:p>
+            <a:pPr algn="ctr" indent="0" marL="0">
+              <a:buNone/>
+            </a:pPr>
+            <a:r>
+              <a:rPr lang="en-US" sz="950" dirty="0">
+                <a:solidFill>
+                  <a:srgbClr val="666666"/>
+                </a:solidFill>
+              </a:rPr>
+              <a:t>1 시간</a:t>
+            </a:r>
+            <a:endParaRPr lang="en-US" sz="950" dirty="0"/>
+          </a:p>
+          <a:p>
+            <a:pPr algn="ctr" indent="0" marL="0">
+              <a:buNone/>
+            </a:pPr>
+            <a:r>
+              <a:rPr lang="en-US" sz="950" dirty="0">
+                <a:solidFill>
+                  <a:srgbClr val="666666"/>
+                </a:solidFill>
+              </a:rPr>
+              <a:t>공휴일 갱신</a:t>
+            </a:r>
+            <a:endParaRPr lang="en-US" sz="950" dirty="0"/>
+          </a:p>
+        </p:txBody>
+      </p:sp>
+      <p:sp>
+        <p:nvSpPr>
+          <p:cNvPr id="27" name="Shape 25"/>
+          <p:cNvSpPr/>
+          <p:nvPr/>
+        </p:nvSpPr>
+        <p:spPr>
+          <a:xfrm>
+            <a:off x="8389620" y="1691640"/>
+            <a:ext cx="0" cy="365760"/>
+          </a:xfrm>
+          <a:prstGeom prst="line">
+            <a:avLst/>
+          </a:prstGeom>
+          <a:noFill/>
+          <a:ln w="15240">
+            <a:solidFill>
+              <a:srgbClr val="000000"/>
+            </a:solidFill>
+            <a:prstDash val="solid"/>
+          </a:ln>
+        </p:spPr>
+      </p:sp>
+      <p:sp>
+        <p:nvSpPr>
+          <p:cNvPr id="28" name="Shape 26"/>
+          <p:cNvSpPr/>
+          <p:nvPr/>
+        </p:nvSpPr>
+        <p:spPr>
+          <a:xfrm>
+            <a:off x="7726680" y="2057400"/>
+            <a:ext cx="1325880" cy="1005840"/>
+          </a:xfrm>
+          <a:prstGeom prst="rect">
+            <a:avLst/>
+          </a:prstGeom>
+          <a:solidFill>
+            <a:srgbClr val="FFFFFF"/>
+          </a:solidFill>
+          <a:ln w="19050">
+            <a:solidFill>
+              <a:srgbClr val="000000"/>
+            </a:solidFill>
+            <a:prstDash val="solid"/>
+          </a:ln>
+        </p:spPr>
+      </p:sp>
+      <p:sp>
+        <p:nvSpPr>
+          <p:cNvPr id="29" name="Text 27"/>
+          <p:cNvSpPr/>
+          <p:nvPr/>
+        </p:nvSpPr>
+        <p:spPr>
+          <a:xfrm>
+            <a:off x="7763256" y="2084832"/>
+            <a:ext cx="1252728" cy="411480"/>
+          </a:xfrm>
+          <a:prstGeom prst="rect">
+            <a:avLst/>
+          </a:prstGeom>
+          <a:noFill/>
+          <a:ln/>
+        </p:spPr>
+        <p:txBody>
+          <a:bodyPr wrap="square" rtlCol="0" anchor="ctr"/>
+          <a:lstStyle/>
+          <a:p>
+            <a:pPr algn="ctr" indent="0" marL="0">
+              <a:buNone/>
+            </a:pPr>
+            <a:r>
+              <a:rPr lang="en-US" sz="850" b="1" dirty="0">
+                <a:solidFill>
+                  <a:srgbClr val="000000"/>
+                </a:solidFill>
+              </a:rPr>
               <a:t>WiFi 체크</a:t>
             </a:r>
-            <a:endParaRPr lang="en-US" sz="900" dirty="0"/>
-          </a:p>
-        </p:txBody>
-      </p:sp>
-      <p:sp>
-        <p:nvSpPr>
-          <p:cNvPr id="26" name="Text 24"/>
-          <p:cNvSpPr/>
-          <p:nvPr/>
-        </p:nvSpPr>
-        <p:spPr>
-          <a:xfrm>
-            <a:off x="7452360" y="2496312"/>
-            <a:ext cx="1554480" cy="548640"/>
-          </a:xfrm>
-          <a:prstGeom prst="rect">
-            <a:avLst/>
-          </a:prstGeom>
-          <a:noFill/>
-          <a:ln/>
-        </p:spPr>
-        <p:txBody>
-          <a:bodyPr wrap="square" rtlCol="0" anchor="ctr"/>
-          <a:lstStyle/>
-          <a:p>
-            <a:pPr algn="ctr" indent="0" marL="0">
+            <a:endParaRPr lang="en-US" sz="850" dirty="0"/>
+          </a:p>
+        </p:txBody>
+      </p:sp>
+      <p:sp>
+        <p:nvSpPr>
+          <p:cNvPr id="30" name="Text 28"/>
+          <p:cNvSpPr/>
+          <p:nvPr/>
+        </p:nvSpPr>
+        <p:spPr>
+          <a:xfrm>
+            <a:off x="7763256" y="2496312"/>
+            <a:ext cx="1252728" cy="548640"/>
+          </a:xfrm>
+          <a:prstGeom prst="rect">
+            <a:avLst/>
+          </a:prstGeom>
+          <a:noFill/>
+          <a:ln/>
+        </p:spPr>
+        <p:txBody>
+          <a:bodyPr wrap="square" rtlCol="0" anchor="ctr"/>
+          <a:lstStyle/>
+          <a:p>
+            <a:pPr algn="ctr" indent="0" marL="0">
+              <a:buNone/>
+            </a:pPr>
+            <a:r>
+              <a:rPr lang="en-US" sz="950" dirty="0">
+                <a:solidFill>
+                  <a:srgbClr val="666666"/>
+                </a:solidFill>
+              </a:rPr>
+              <a:t>5 s</a:t>
+            </a:r>
+            <a:endParaRPr lang="en-US" sz="950" dirty="0"/>
+          </a:p>
+          <a:p>
+            <a:pPr algn="ctr" indent="0" marL="0">
+              <a:buNone/>
+            </a:pPr>
+            <a:r>
+              <a:rPr lang="en-US" sz="950" dirty="0">
+                <a:solidFill>
+                  <a:srgbClr val="666666"/>
+                </a:solidFill>
+              </a:rPr>
+              <a:t>WiFiMulti</a:t>
+            </a:r>
+            <a:endParaRPr lang="en-US" sz="950" dirty="0"/>
+          </a:p>
+          <a:p>
+            <a:pPr algn="ctr" indent="0" marL="0">
+              <a:buNone/>
+            </a:pPr>
+            <a:r>
+              <a:rPr lang="en-US" sz="950" dirty="0">
+                <a:solidFill>
+                  <a:srgbClr val="666666"/>
+                </a:solidFill>
+              </a:rPr>
+              <a:t>재접속</a:t>
+            </a:r>
+            <a:endParaRPr lang="en-US" sz="950" dirty="0"/>
+          </a:p>
+        </p:txBody>
+      </p:sp>
+      <p:sp>
+        <p:nvSpPr>
+          <p:cNvPr id="31" name="Shape 29"/>
+          <p:cNvSpPr/>
+          <p:nvPr/>
+        </p:nvSpPr>
+        <p:spPr>
+          <a:xfrm>
+            <a:off x="274320" y="3154680"/>
+            <a:ext cx="8595360" cy="457200"/>
+          </a:xfrm>
+          <a:prstGeom prst="rect">
+            <a:avLst/>
+          </a:prstGeom>
+          <a:solidFill>
+            <a:srgbClr val="FFFFFF"/>
+          </a:solidFill>
+          <a:ln w="12700">
+            <a:solidFill>
+              <a:srgbClr val="000000"/>
+            </a:solidFill>
+            <a:prstDash val="solid"/>
+          </a:ln>
+        </p:spPr>
+      </p:sp>
+      <p:sp>
+        <p:nvSpPr>
+          <p:cNvPr id="32" name="Shape 30"/>
+          <p:cNvSpPr/>
+          <p:nvPr/>
+        </p:nvSpPr>
+        <p:spPr>
+          <a:xfrm>
+            <a:off x="274320" y="3154680"/>
+            <a:ext cx="2560320" cy="457200"/>
+          </a:xfrm>
+          <a:prstGeom prst="rect">
+            <a:avLst/>
+          </a:prstGeom>
+          <a:solidFill>
+            <a:srgbClr val="222222"/>
+          </a:solidFill>
+          <a:ln w="12700">
+            <a:solidFill>
+              <a:srgbClr val="000000"/>
+            </a:solidFill>
+            <a:prstDash val="solid"/>
+          </a:ln>
+        </p:spPr>
+      </p:sp>
+      <p:sp>
+        <p:nvSpPr>
+          <p:cNvPr id="33" name="Text 31"/>
+          <p:cNvSpPr/>
+          <p:nvPr/>
+        </p:nvSpPr>
+        <p:spPr>
+          <a:xfrm>
+            <a:off x="274320" y="3154680"/>
+            <a:ext cx="2560320" cy="457200"/>
+          </a:xfrm>
+          <a:prstGeom prst="rect">
+            <a:avLst/>
+          </a:prstGeom>
+          <a:noFill/>
+          <a:ln/>
+        </p:spPr>
+        <p:txBody>
+          <a:bodyPr wrap="square" rtlCol="0" anchor="ctr"/>
+          <a:lstStyle/>
+          <a:p>
+            <a:pPr algn="ctr" indent="0" marL="0">
+              <a:buNone/>
+            </a:pPr>
+            <a:r>
+              <a:rPr lang="en-US" sz="1200" b="1" dirty="0">
+                <a:solidFill>
+                  <a:srgbClr val="FFFFFF"/>
+                </a:solidFill>
+              </a:rPr>
+              <a:t>날씨 갱신 전략</a:t>
+            </a:r>
+            <a:endParaRPr lang="en-US" sz="1200" dirty="0"/>
+          </a:p>
+        </p:txBody>
+      </p:sp>
+      <p:sp>
+        <p:nvSpPr>
+          <p:cNvPr id="34" name="Text 32"/>
+          <p:cNvSpPr/>
+          <p:nvPr/>
+        </p:nvSpPr>
+        <p:spPr>
+          <a:xfrm>
+            <a:off x="2926080" y="3172968"/>
+            <a:ext cx="5760720" cy="411480"/>
+          </a:xfrm>
+          <a:prstGeom prst="rect">
+            <a:avLst/>
+          </a:prstGeom>
+          <a:noFill/>
+          <a:ln/>
+        </p:spPr>
+        <p:txBody>
+          <a:bodyPr wrap="square" rtlCol="0" anchor="ctr"/>
+          <a:lstStyle/>
+          <a:p>
+            <a:pPr indent="0" marL="0">
               <a:buNone/>
             </a:pPr>
             <a:r>
               <a:rPr lang="en-US" sz="1000" dirty="0">
                 <a:solidFill>
-                  <a:srgbClr val="666666"/>
-                </a:solidFill>
-              </a:rPr>
-              <a:t>5 s</a:t>
+                  <a:srgbClr val="222222"/>
+                </a:solidFill>
+              </a:rPr>
+              <a:t>fetchWeatherWttr() — wValid=false 60초 재시도 / wValid=true 5분 정기 갱신  |  wttr.in HTTPS + 텍스트 포맷 (?format=%t|%C)  |  온도=wttr.in / 습도=DHT11 실내 센서</a:t>
             </a:r>
             <a:endParaRPr lang="en-US" sz="1000" dirty="0"/>
           </a:p>
-          <a:p>
-            <a:pPr algn="ctr" indent="0" marL="0">
-              <a:buNone/>
-            </a:pPr>
-            <a:r>
-              <a:rPr lang="en-US" sz="1000" dirty="0">
-                <a:solidFill>
-                  <a:srgbClr val="666666"/>
-                </a:solidFill>
-              </a:rPr>
-              <a:t>WiFiMulti</a:t>
-            </a:r>
-            <a:endParaRPr lang="en-US" sz="1000" dirty="0"/>
-          </a:p>
-          <a:p>
-            <a:pPr algn="ctr" indent="0" marL="0">
-              <a:buNone/>
-            </a:pPr>
-            <a:r>
-              <a:rPr lang="en-US" sz="1000" dirty="0">
-                <a:solidFill>
-                  <a:srgbClr val="666666"/>
-                </a:solidFill>
-              </a:rPr>
-              <a:t>재접속</a:t>
-            </a:r>
-            <a:endParaRPr lang="en-US" sz="1000" dirty="0"/>
-          </a:p>
-        </p:txBody>
-      </p:sp>
-      <p:sp>
-        <p:nvSpPr>
-          <p:cNvPr id="27" name="Shape 25"/>
-          <p:cNvSpPr/>
-          <p:nvPr/>
-        </p:nvSpPr>
-        <p:spPr>
-          <a:xfrm>
-            <a:off x="274320" y="3291840"/>
-            <a:ext cx="8595360" cy="1600200"/>
+        </p:txBody>
+      </p:sp>
+      <p:sp>
+        <p:nvSpPr>
+          <p:cNvPr id="35" name="Shape 33"/>
+          <p:cNvSpPr/>
+          <p:nvPr/>
+        </p:nvSpPr>
+        <p:spPr>
+          <a:xfrm>
+            <a:off x="274320" y="3703320"/>
+            <a:ext cx="8595360" cy="1371600"/>
           </a:xfrm>
           <a:prstGeom prst="rect">
             <a:avLst/>
@@ -7402,14 +7658,14 @@
       </p:sp>
       <p:sp>
         <p:nvSpPr>
-          <p:cNvPr id="28" name="Shape 26"/>
-          <p:cNvSpPr/>
-          <p:nvPr/>
-        </p:nvSpPr>
-        <p:spPr>
-          <a:xfrm>
-            <a:off x="274320" y="3291840"/>
-            <a:ext cx="8595360" cy="384048"/>
+          <p:cNvPr id="36" name="Shape 34"/>
+          <p:cNvSpPr/>
+          <p:nvPr/>
+        </p:nvSpPr>
+        <p:spPr>
+          <a:xfrm>
+            <a:off x="274320" y="3703320"/>
+            <a:ext cx="8595360" cy="347472"/>
           </a:xfrm>
           <a:prstGeom prst="rect">
             <a:avLst/>
@@ -7427,50 +7683,50 @@
       </p:sp>
       <p:sp>
         <p:nvSpPr>
-          <p:cNvPr id="29" name="Text 27"/>
-          <p:cNvSpPr/>
-          <p:nvPr/>
-        </p:nvSpPr>
-        <p:spPr>
-          <a:xfrm>
-            <a:off x="274320" y="3291840"/>
-            <a:ext cx="8595360" cy="384048"/>
-          </a:xfrm>
-          <a:prstGeom prst="rect">
-            <a:avLst/>
-          </a:prstGeom>
-          <a:noFill/>
-          <a:ln/>
-        </p:spPr>
-        <p:txBody>
-          <a:bodyPr wrap="square" rtlCol="0" anchor="ctr"/>
-          <a:lstStyle/>
-          <a:p>
-            <a:pPr algn="ctr" indent="0" marL="0">
-              <a:buNone/>
-            </a:pPr>
-            <a:r>
-              <a:rPr lang="en-US" sz="1300" b="1" dirty="0">
+          <p:cNvPr id="37" name="Text 35"/>
+          <p:cNvSpPr/>
+          <p:nvPr/>
+        </p:nvSpPr>
+        <p:spPr>
+          <a:xfrm>
+            <a:off x="274320" y="3703320"/>
+            <a:ext cx="8595360" cy="347472"/>
+          </a:xfrm>
+          <a:prstGeom prst="rect">
+            <a:avLst/>
+          </a:prstGeom>
+          <a:noFill/>
+          <a:ln/>
+        </p:spPr>
+        <p:txBody>
+          <a:bodyPr wrap="square" rtlCol="0" anchor="ctr"/>
+          <a:lstStyle/>
+          <a:p>
+            <a:pPr algn="ctr" indent="0" marL="0">
+              <a:buNone/>
+            </a:pPr>
+            <a:r>
+              <a:rPr lang="en-US" sz="1200" b="1" dirty="0">
                 <a:solidFill>
                   <a:srgbClr val="FFFFFF"/>
                 </a:solidFill>
               </a:rPr>
               <a:t>drawFrame()  내부 분기 흐름</a:t>
             </a:r>
-            <a:endParaRPr lang="en-US" sz="1300" dirty="0"/>
-          </a:p>
-        </p:txBody>
-      </p:sp>
-      <p:sp>
-        <p:nvSpPr>
-          <p:cNvPr id="30" name="Text 28"/>
-          <p:cNvSpPr/>
-          <p:nvPr/>
-        </p:nvSpPr>
-        <p:spPr>
-          <a:xfrm>
-            <a:off x="457200" y="3703320"/>
-            <a:ext cx="2377440" cy="274320"/>
+            <a:endParaRPr lang="en-US" sz="1200" dirty="0"/>
+          </a:p>
+        </p:txBody>
+      </p:sp>
+      <p:sp>
+        <p:nvSpPr>
+          <p:cNvPr id="38" name="Text 36"/>
+          <p:cNvSpPr/>
+          <p:nvPr/>
+        </p:nvSpPr>
+        <p:spPr>
+          <a:xfrm>
+            <a:off x="457200" y="4087368"/>
+            <a:ext cx="2377440" cy="219456"/>
           </a:xfrm>
           <a:prstGeom prst="rect">
             <a:avLst/>
@@ -7486,27 +7742,27 @@
               <a:buNone/>
             </a:pPr>
             <a:r>
-              <a:rPr lang="en-US" sz="1100" b="1" dirty="0">
+              <a:rPr lang="en-US" sz="1050" b="1" dirty="0">
                 <a:solidFill>
                   <a:srgbClr val="000000"/>
                 </a:solidFill>
               </a:rPr>
               <a:t>▶ WiFi 미접속?</a:t>
             </a:r>
-            <a:endParaRPr lang="en-US" sz="1100" dirty="0"/>
-          </a:p>
-        </p:txBody>
-      </p:sp>
-      <p:sp>
-        <p:nvSpPr>
-          <p:cNvPr id="31" name="Text 29"/>
-          <p:cNvSpPr/>
-          <p:nvPr/>
-        </p:nvSpPr>
-        <p:spPr>
-          <a:xfrm>
-            <a:off x="2834640" y="3703320"/>
-            <a:ext cx="5852160" cy="274320"/>
+            <a:endParaRPr lang="en-US" sz="1050" dirty="0"/>
+          </a:p>
+        </p:txBody>
+      </p:sp>
+      <p:sp>
+        <p:nvSpPr>
+          <p:cNvPr id="39" name="Text 37"/>
+          <p:cNvSpPr/>
+          <p:nvPr/>
+        </p:nvSpPr>
+        <p:spPr>
+          <a:xfrm>
+            <a:off x="2834640" y="4087368"/>
+            <a:ext cx="5852160" cy="219456"/>
           </a:xfrm>
           <a:prstGeom prst="rect">
             <a:avLst/>
@@ -7522,27 +7778,27 @@
               <a:buNone/>
             </a:pPr>
             <a:r>
-              <a:rPr lang="en-US" sz="1100" dirty="0">
+              <a:rPr lang="en-US" sz="1050" dirty="0">
                 <a:solidFill>
                   <a:srgbClr val="222222"/>
                 </a:solidFill>
               </a:rPr>
               <a:t>→  'WiFi ?' 적색 1Hz 깜빡임 → return</a:t>
             </a:r>
-            <a:endParaRPr lang="en-US" sz="1100" dirty="0"/>
-          </a:p>
-        </p:txBody>
-      </p:sp>
-      <p:sp>
-        <p:nvSpPr>
-          <p:cNvPr id="32" name="Text 30"/>
-          <p:cNvSpPr/>
-          <p:nvPr/>
-        </p:nvSpPr>
-        <p:spPr>
-          <a:xfrm>
-            <a:off x="457200" y="3968496"/>
-            <a:ext cx="2377440" cy="274320"/>
+            <a:endParaRPr lang="en-US" sz="1050" dirty="0"/>
+          </a:p>
+        </p:txBody>
+      </p:sp>
+      <p:sp>
+        <p:nvSpPr>
+          <p:cNvPr id="40" name="Text 38"/>
+          <p:cNvSpPr/>
+          <p:nvPr/>
+        </p:nvSpPr>
+        <p:spPr>
+          <a:xfrm>
+            <a:off x="457200" y="4288536"/>
+            <a:ext cx="2377440" cy="219456"/>
           </a:xfrm>
           <a:prstGeom prst="rect">
             <a:avLst/>
@@ -7558,27 +7814,27 @@
               <a:buNone/>
             </a:pPr>
             <a:r>
-              <a:rPr lang="en-US" sz="1100" b="1" dirty="0">
+              <a:rPr lang="en-US" sz="1050" b="1" dirty="0">
                 <a:solidFill>
                   <a:srgbClr val="000000"/>
                 </a:solidFill>
               </a:rPr>
               <a:t>▶ 야간 모드?</a:t>
             </a:r>
-            <a:endParaRPr lang="en-US" sz="1100" dirty="0"/>
-          </a:p>
-        </p:txBody>
-      </p:sp>
-      <p:sp>
-        <p:nvSpPr>
-          <p:cNvPr id="33" name="Text 31"/>
-          <p:cNvSpPr/>
-          <p:nvPr/>
-        </p:nvSpPr>
-        <p:spPr>
-          <a:xfrm>
-            <a:off x="2834640" y="3968496"/>
-            <a:ext cx="5852160" cy="274320"/>
+            <a:endParaRPr lang="en-US" sz="1050" dirty="0"/>
+          </a:p>
+        </p:txBody>
+      </p:sp>
+      <p:sp>
+        <p:nvSpPr>
+          <p:cNvPr id="41" name="Text 39"/>
+          <p:cNvSpPr/>
+          <p:nvPr/>
+        </p:nvSpPr>
+        <p:spPr>
+          <a:xfrm>
+            <a:off x="2834640" y="4288536"/>
+            <a:ext cx="5852160" cy="219456"/>
           </a:xfrm>
           <a:prstGeom prst="rect">
             <a:avLst/>
@@ -7594,27 +7850,27 @@
               <a:buNone/>
             </a:pPr>
             <a:r>
-              <a:rPr lang="en-US" sz="1100" dirty="0">
+              <a:rPr lang="en-US" sz="1050" dirty="0">
                 <a:solidFill>
                   <a:srgbClr val="222222"/>
                 </a:solidFill>
               </a:rPr>
               <a:t>→  CDS raw &gt; 960 → 시계만 + 밝기 1~4 비례 (스크롤 생략)</a:t>
             </a:r>
-            <a:endParaRPr lang="en-US" sz="1100" dirty="0"/>
-          </a:p>
-        </p:txBody>
-      </p:sp>
-      <p:sp>
-        <p:nvSpPr>
-          <p:cNvPr id="34" name="Text 32"/>
-          <p:cNvSpPr/>
-          <p:nvPr/>
-        </p:nvSpPr>
-        <p:spPr>
-          <a:xfrm>
-            <a:off x="457200" y="4233672"/>
-            <a:ext cx="2377440" cy="274320"/>
+            <a:endParaRPr lang="en-US" sz="1050" dirty="0"/>
+          </a:p>
+        </p:txBody>
+      </p:sp>
+      <p:sp>
+        <p:nvSpPr>
+          <p:cNvPr id="42" name="Text 40"/>
+          <p:cNvSpPr/>
+          <p:nvPr/>
+        </p:nvSpPr>
+        <p:spPr>
+          <a:xfrm>
+            <a:off x="457200" y="4489704"/>
+            <a:ext cx="2377440" cy="219456"/>
           </a:xfrm>
           <a:prstGeom prst="rect">
             <a:avLst/>
@@ -7630,27 +7886,27 @@
               <a:buNone/>
             </a:pPr>
             <a:r>
-              <a:rPr lang="en-US" sz="1100" b="1" dirty="0">
+              <a:rPr lang="en-US" sz="1050" b="1" dirty="0">
                 <a:solidFill>
                   <a:srgbClr val="000000"/>
                 </a:solidFill>
               </a:rPr>
               <a:t>▶ phase &lt; 15s?</a:t>
             </a:r>
-            <a:endParaRPr lang="en-US" sz="1100" dirty="0"/>
-          </a:p>
-        </p:txBody>
-      </p:sp>
-      <p:sp>
-        <p:nvSpPr>
-          <p:cNvPr id="35" name="Text 33"/>
-          <p:cNvSpPr/>
-          <p:nvPr/>
-        </p:nvSpPr>
-        <p:spPr>
-          <a:xfrm>
-            <a:off x="2834640" y="4233672"/>
-            <a:ext cx="5852160" cy="274320"/>
+            <a:endParaRPr lang="en-US" sz="1050" dirty="0"/>
+          </a:p>
+        </p:txBody>
+      </p:sp>
+      <p:sp>
+        <p:nvSpPr>
+          <p:cNvPr id="43" name="Text 41"/>
+          <p:cNvSpPr/>
+          <p:nvPr/>
+        </p:nvSpPr>
+        <p:spPr>
+          <a:xfrm>
+            <a:off x="2834640" y="4489704"/>
+            <a:ext cx="5852160" cy="219456"/>
           </a:xfrm>
           <a:prstGeom prst="rect">
             <a:avLst/>
@@ -7666,27 +7922,27 @@
               <a:buNone/>
             </a:pPr>
             <a:r>
-              <a:rPr lang="en-US" sz="1100" dirty="0">
+              <a:rPr lang="en-US" sz="1050" dirty="0">
                 <a:solidFill>
                   <a:srgbClr val="222222"/>
                 </a:solidFill>
               </a:rPr>
               <a:t>→  시계 표시  HH:MM  (커스텀 폰트, 콜론 4점 회전)</a:t>
             </a:r>
-            <a:endParaRPr lang="en-US" sz="1100" dirty="0"/>
-          </a:p>
-        </p:txBody>
-      </p:sp>
-      <p:sp>
-        <p:nvSpPr>
-          <p:cNvPr id="36" name="Text 34"/>
-          <p:cNvSpPr/>
-          <p:nvPr/>
-        </p:nvSpPr>
-        <p:spPr>
-          <a:xfrm>
-            <a:off x="457200" y="4498848"/>
-            <a:ext cx="2377440" cy="274320"/>
+            <a:endParaRPr lang="en-US" sz="1050" dirty="0"/>
+          </a:p>
+        </p:txBody>
+      </p:sp>
+      <p:sp>
+        <p:nvSpPr>
+          <p:cNvPr id="44" name="Text 42"/>
+          <p:cNvSpPr/>
+          <p:nvPr/>
+        </p:nvSpPr>
+        <p:spPr>
+          <a:xfrm>
+            <a:off x="457200" y="4690872"/>
+            <a:ext cx="2377440" cy="219456"/>
           </a:xfrm>
           <a:prstGeom prst="rect">
             <a:avLst/>
@@ -7702,27 +7958,27 @@
               <a:buNone/>
             </a:pPr>
             <a:r>
-              <a:rPr lang="en-US" sz="1100" b="1" dirty="0">
+              <a:rPr lang="en-US" sz="1050" b="1" dirty="0">
                 <a:solidFill>
                   <a:srgbClr val="000000"/>
                 </a:solidFill>
               </a:rPr>
               <a:t>▶ phase &gt;= 15s?</a:t>
             </a:r>
-            <a:endParaRPr lang="en-US" sz="1100" dirty="0"/>
-          </a:p>
-        </p:txBody>
-      </p:sp>
-      <p:sp>
-        <p:nvSpPr>
-          <p:cNvPr id="37" name="Text 35"/>
-          <p:cNvSpPr/>
-          <p:nvPr/>
-        </p:nvSpPr>
-        <p:spPr>
-          <a:xfrm>
-            <a:off x="2834640" y="4498848"/>
-            <a:ext cx="5852160" cy="274320"/>
+            <a:endParaRPr lang="en-US" sz="1050" dirty="0"/>
+          </a:p>
+        </p:txBody>
+      </p:sp>
+      <p:sp>
+        <p:nvSpPr>
+          <p:cNvPr id="45" name="Text 43"/>
+          <p:cNvSpPr/>
+          <p:nvPr/>
+        </p:nvSpPr>
+        <p:spPr>
+          <a:xfrm>
+            <a:off x="2834640" y="4690872"/>
+            <a:ext cx="5852160" cy="219456"/>
           </a:xfrm>
           <a:prstGeom prst="rect">
             <a:avLst/>
@@ -7738,27 +7994,27 @@
               <a:buNone/>
             </a:pPr>
             <a:r>
-              <a:rPr lang="en-US" sz="1100" dirty="0">
+              <a:rPr lang="en-US" sz="1050" dirty="0">
                 <a:solidFill>
                   <a:srgbClr val="222222"/>
                 </a:solidFill>
               </a:rPr>
               <a:t>→  날짜→기온+습도→날씨+아이콘 통합 스크롤</a:t>
             </a:r>
-            <a:endParaRPr lang="en-US" sz="1100" dirty="0"/>
-          </a:p>
-        </p:txBody>
-      </p:sp>
-      <p:sp>
-        <p:nvSpPr>
-          <p:cNvPr id="38" name="Text 36"/>
-          <p:cNvSpPr/>
-          <p:nvPr/>
-        </p:nvSpPr>
-        <p:spPr>
-          <a:xfrm>
-            <a:off x="457200" y="4764024"/>
-            <a:ext cx="2377440" cy="274320"/>
+            <a:endParaRPr lang="en-US" sz="1050" dirty="0"/>
+          </a:p>
+        </p:txBody>
+      </p:sp>
+      <p:sp>
+        <p:nvSpPr>
+          <p:cNvPr id="46" name="Text 44"/>
+          <p:cNvSpPr/>
+          <p:nvPr/>
+        </p:nvSpPr>
+        <p:spPr>
+          <a:xfrm>
+            <a:off x="457200" y="4892040"/>
+            <a:ext cx="2377440" cy="219456"/>
           </a:xfrm>
           <a:prstGeom prst="rect">
             <a:avLst/>
@@ -7774,27 +8030,27 @@
               <a:buNone/>
             </a:pPr>
             <a:r>
-              <a:rPr lang="en-US" sz="1100" b="1" dirty="0">
+              <a:rPr lang="en-US" sz="1050" b="1" dirty="0">
                 <a:solidFill>
                   <a:srgbClr val="000000"/>
                 </a:solidFill>
               </a:rPr>
               <a:t>▶ 스크롤 완료?</a:t>
             </a:r>
-            <a:endParaRPr lang="en-US" sz="1100" dirty="0"/>
-          </a:p>
-        </p:txBody>
-      </p:sp>
-      <p:sp>
-        <p:nvSpPr>
-          <p:cNvPr id="39" name="Text 37"/>
-          <p:cNvSpPr/>
-          <p:nvPr/>
-        </p:nvSpPr>
-        <p:spPr>
-          <a:xfrm>
-            <a:off x="2834640" y="4764024"/>
-            <a:ext cx="5852160" cy="274320"/>
+            <a:endParaRPr lang="en-US" sz="1050" dirty="0"/>
+          </a:p>
+        </p:txBody>
+      </p:sp>
+      <p:sp>
+        <p:nvSpPr>
+          <p:cNvPr id="47" name="Text 45"/>
+          <p:cNvSpPr/>
+          <p:nvPr/>
+        </p:nvSpPr>
+        <p:spPr>
+          <a:xfrm>
+            <a:off x="2834640" y="4892040"/>
+            <a:ext cx="5852160" cy="219456"/>
           </a:xfrm>
           <a:prstGeom prst="rect">
             <a:avLst/>
@@ -7810,14 +8066,14 @@
               <a:buNone/>
             </a:pPr>
             <a:r>
-              <a:rPr lang="en-US" sz="1100" dirty="0">
+              <a:rPr lang="en-US" sz="1050" dirty="0">
                 <a:solidFill>
                   <a:srgbClr val="222222"/>
                 </a:solidFill>
               </a:rPr>
               <a:t>→  즉시 시계로 전환 (scrollDone 플래그)</a:t>
             </a:r>
-            <a:endParaRPr lang="en-US" sz="1100" dirty="0"/>
+            <a:endParaRPr lang="en-US" sz="1050" dirty="0"/>
           </a:p>
         </p:txBody>
       </p:sp>
@@ -7879,7 +8135,7 @@
                 <a:ea typeface="Arial Black" pitchFamily="34" charset="-122"/>
                 <a:cs typeface="Arial Black" pitchFamily="34" charset="-120"/>
               </a:rPr>
-              <a:t>날씨 정보 수신 경로  (기상청 API Hub)</a:t>
+              <a:t>날씨 정보 수신 경로  (wttr.in)</a:t>
             </a:r>
             <a:endParaRPr lang="en-US" sz="3000" dirty="0"/>
           </a:p>
@@ -8150,7 +8406,7 @@
                   <a:srgbClr val="666666"/>
                 </a:solidFill>
               </a:rPr>
-              <a:t>위도 / 경도</a:t>
+              <a:t>(Seoul 등)</a:t>
             </a:r>
             <a:endParaRPr lang="en-US" sz="1100" dirty="0"/>
           </a:p>
@@ -8235,7 +8491,7 @@
                   <a:srgbClr val="000000"/>
                 </a:solidFill>
               </a:rPr>
-              <a:t>apihub.kma</a:t>
+              <a:t>wttr.in</a:t>
             </a:r>
             <a:endParaRPr lang="en-US" sz="1200" dirty="0"/>
           </a:p>
@@ -8249,7 +8505,7 @@
                   <a:srgbClr val="000000"/>
                 </a:solidFill>
               </a:rPr>
-              <a:t>.go.kr</a:t>
+              <a:t>(HTTPS)</a:t>
             </a:r>
             <a:endParaRPr lang="en-US" sz="1200" dirty="0"/>
           </a:p>
@@ -8285,7 +8541,7 @@
                   <a:srgbClr val="666666"/>
                 </a:solidFill>
               </a:rPr>
-              <a:t>ta / hm / ww</a:t>
+              <a:t>기온 + 날씨 설명</a:t>
             </a:r>
             <a:endParaRPr lang="en-US" sz="1100" dirty="0"/>
           </a:p>
@@ -8299,7 +8555,7 @@
                   <a:srgbClr val="666666"/>
                 </a:solidFill>
               </a:rPr>
-              <a:t>(순차 3회)</a:t>
+              <a:t>텍스트 포맷</a:t>
             </a:r>
             <a:endParaRPr lang="en-US" sz="1100" dirty="0"/>
           </a:p>
@@ -8384,7 +8640,7 @@
                   <a:srgbClr val="000000"/>
                 </a:solidFill>
               </a:rPr>
-              <a:t>ww 코드 변환</a:t>
+              <a:t>descToCondition()</a:t>
             </a:r>
             <a:endParaRPr lang="en-US" sz="1200" dirty="0"/>
           </a:p>
@@ -8420,7 +8676,7 @@
                   <a:srgbClr val="666666"/>
                 </a:solidFill>
               </a:rPr>
-              <a:t>WMO 코드</a:t>
+              <a:t>영문 설명</a:t>
             </a:r>
             <a:endParaRPr lang="en-US" sz="1100" dirty="0"/>
           </a:p>
@@ -8434,7 +8690,7 @@
                   <a:srgbClr val="666666"/>
                 </a:solidFill>
               </a:rPr>
-              <a:t>→ 조건 문자열</a:t>
+              <a:t>→ 조건 매핑</a:t>
             </a:r>
             <a:endParaRPr lang="en-US" sz="1100" dirty="0"/>
           </a:p>
@@ -8633,7 +8889,7 @@
                 <a:ea typeface="Consolas" pitchFamily="34" charset="-122"/>
                 <a:cs typeface="Consolas" pitchFamily="34" charset="-120"/>
               </a:rPr>
-              <a:t>ww 0~2  : Sunny (맑음)</a:t>
+              <a:t>partly cloudy  → PCloud</a:t>
             </a:r>
             <a:endParaRPr lang="en-US" sz="900" dirty="0"/>
           </a:p>
@@ -8672,7 +8928,7 @@
                 <a:ea typeface="Consolas" pitchFamily="34" charset="-122"/>
                 <a:cs typeface="Consolas" pitchFamily="34" charset="-120"/>
               </a:rPr>
-              <a:t>ww 3~9  : Cloud (구름)</a:t>
+              <a:t>rain/drizzle   → Rain</a:t>
             </a:r>
             <a:endParaRPr lang="en-US" sz="900" dirty="0"/>
           </a:p>
@@ -8711,7 +8967,7 @@
                 <a:ea typeface="Consolas" pitchFamily="34" charset="-122"/>
                 <a:cs typeface="Consolas" pitchFamily="34" charset="-120"/>
               </a:rPr>
-              <a:t>ww 40~49: Fog   (안개)</a:t>
+              <a:t>snow/sleet     → Snow</a:t>
             </a:r>
             <a:endParaRPr lang="en-US" sz="900" dirty="0"/>
           </a:p>
@@ -8750,7 +9006,7 @@
                 <a:ea typeface="Consolas" pitchFamily="34" charset="-122"/>
                 <a:cs typeface="Consolas" pitchFamily="34" charset="-120"/>
               </a:rPr>
-              <a:t>ww 50~69: Rain  (비)</a:t>
+              <a:t>fog/mist/haze  → Fog</a:t>
             </a:r>
             <a:endParaRPr lang="en-US" sz="900" dirty="0"/>
           </a:p>
@@ -8789,7 +9045,7 @@
                 <a:ea typeface="Consolas" pitchFamily="34" charset="-122"/>
                 <a:cs typeface="Consolas" pitchFamily="34" charset="-120"/>
               </a:rPr>
-              <a:t>ww 70~79: Snow  (눈)</a:t>
+              <a:t>thunder/storm  → Storm</a:t>
             </a:r>
             <a:endParaRPr lang="en-US" sz="900" dirty="0"/>
           </a:p>
@@ -8828,7 +9084,7 @@
                 <a:ea typeface="Consolas" pitchFamily="34" charset="-122"/>
                 <a:cs typeface="Consolas" pitchFamily="34" charset="-120"/>
               </a:rPr>
-              <a:t>ww 95~99: Storm (뇌우)</a:t>
+              <a:t>sunny/clear    → Sunny</a:t>
             </a:r>
             <a:endParaRPr lang="en-US" sz="900" dirty="0"/>
           </a:p>
@@ -8914,7 +9170,7 @@
                   <a:srgbClr val="FFFFFF"/>
                 </a:solidFill>
               </a:rPr>
-              <a:t>HTTPS 보안</a:t>
+              <a:t>HTTPS 방식</a:t>
             </a:r>
             <a:endParaRPr lang="en-US" sz="1200" dirty="0"/>
           </a:p>
@@ -8950,7 +9206,7 @@
                   <a:srgbClr val="222222"/>
                 </a:solidFill>
               </a:rPr>
-              <a:t>WiFiClientSecure + setInsecure()</a:t>
+              <a:t>WiFiClientSecure</a:t>
             </a:r>
             <a:endParaRPr lang="en-US" sz="1100" dirty="0"/>
           </a:p>
@@ -8964,7 +9220,35 @@
                   <a:srgbClr val="222222"/>
                 </a:solidFill>
               </a:rPr>
-              <a:t>BearSSL RX 1024 / TX 512 bytes</a:t>
+              <a:t>+ setInsecure()</a:t>
+            </a:r>
+            <a:endParaRPr lang="en-US" sz="1100" dirty="0"/>
+          </a:p>
+          <a:p>
+            <a:pPr indent="0" marL="0">
+              <a:buNone/>
+            </a:pPr>
+            <a:r>
+              <a:rPr lang="en-US" sz="1100" dirty="0">
+                <a:solidFill>
+                  <a:srgbClr val="222222"/>
+                </a:solidFill>
+              </a:rPr>
+              <a:t>Cloudflare MFLN</a:t>
+            </a:r>
+            <a:endParaRPr lang="en-US" sz="1100" dirty="0"/>
+          </a:p>
+          <a:p>
+            <a:pPr indent="0" marL="0">
+              <a:buNone/>
+            </a:pPr>
+            <a:r>
+              <a:rPr lang="en-US" sz="1100" dirty="0">
+                <a:solidFill>
+                  <a:srgbClr val="222222"/>
+                </a:solidFill>
+              </a:rPr>
+              <a:t>→ 4096 RX 버퍼</a:t>
             </a:r>
             <a:endParaRPr lang="en-US" sz="1100" dirty="0"/>
           </a:p>
@@ -9050,7 +9334,7 @@
                   <a:srgbClr val="FFFFFF"/>
                 </a:solidFill>
               </a:rPr>
-              <a:t>관측 요소</a:t>
+              <a:t>텍스트 포맷</a:t>
             </a:r>
             <a:endParaRPr lang="en-US" sz="1200" dirty="0"/>
           </a:p>
@@ -9086,7 +9370,7 @@
                   <a:srgbClr val="222222"/>
                 </a:solidFill>
               </a:rPr>
-              <a:t>ta: 기온(°C)</a:t>
+              <a:t>?format=%t|%C</a:t>
             </a:r>
             <a:endParaRPr lang="en-US" sz="1100" dirty="0"/>
           </a:p>
@@ -9100,7 +9384,7 @@
                   <a:srgbClr val="222222"/>
                 </a:solidFill>
               </a:rPr>
-              <a:t>hm: 습도(%)</a:t>
+              <a:t>응답 ~30 bytes</a:t>
             </a:r>
             <a:endParaRPr lang="en-US" sz="1100" dirty="0"/>
           </a:p>
@@ -9114,7 +9398,21 @@
                   <a:srgbClr val="222222"/>
                 </a:solidFill>
               </a:rPr>
-              <a:t>ww: 현천코드(WMO)</a:t>
+              <a:t>→ split '|'</a:t>
+            </a:r>
+            <a:endParaRPr lang="en-US" sz="1100" dirty="0"/>
+          </a:p>
+          <a:p>
+            <a:pPr indent="0" marL="0">
+              <a:buNone/>
+            </a:pPr>
+            <a:r>
+              <a:rPr lang="en-US" sz="1100" dirty="0">
+                <a:solidFill>
+                  <a:srgbClr val="222222"/>
+                </a:solidFill>
+              </a:rPr>
+              <a:t>JSON 파싱 없음</a:t>
             </a:r>
             <a:endParaRPr lang="en-US" sz="1100" dirty="0"/>
           </a:p>
@@ -9200,7 +9498,7 @@
                   <a:srgbClr val="FFFFFF"/>
                 </a:solidFill>
               </a:rPr>
-              <a:t>갱신 주기</a:t>
+              <a:t>갱신 전략</a:t>
             </a:r>
             <a:endParaRPr lang="en-US" sz="1200" dirty="0"/>
           </a:p>
@@ -9236,7 +9534,7 @@
                   <a:srgbClr val="222222"/>
                 </a:solidFill>
               </a:rPr>
-              <a:t>1분 (3회 순차 요청)</a:t>
+              <a:t>wValid=false:</a:t>
             </a:r>
             <a:endParaRPr lang="en-US" sz="1100" dirty="0"/>
           </a:p>
@@ -9250,7 +9548,35 @@
                   <a:srgbClr val="222222"/>
                 </a:solidFill>
               </a:rPr>
-              <a:t>결측(-9999) 시 이전값 유지</a:t>
+              <a:t>60초 재시도</a:t>
+            </a:r>
+            <a:endParaRPr lang="en-US" sz="1100" dirty="0"/>
+          </a:p>
+          <a:p>
+            <a:pPr indent="0" marL="0">
+              <a:buNone/>
+            </a:pPr>
+            <a:r>
+              <a:rPr lang="en-US" sz="1100" dirty="0">
+                <a:solidFill>
+                  <a:srgbClr val="222222"/>
+                </a:solidFill>
+              </a:rPr>
+              <a:t>wValid=true:</a:t>
+            </a:r>
+            <a:endParaRPr lang="en-US" sz="1100" dirty="0"/>
+          </a:p>
+          <a:p>
+            <a:pPr indent="0" marL="0">
+              <a:buNone/>
+            </a:pPr>
+            <a:r>
+              <a:rPr lang="en-US" sz="1100" dirty="0">
+                <a:solidFill>
+                  <a:srgbClr val="222222"/>
+                </a:solidFill>
+              </a:rPr>
+              <a:t>5분 정기 갱신</a:t>
             </a:r>
             <a:endParaRPr lang="en-US" sz="1100" dirty="0"/>
           </a:p>
@@ -9336,7 +9662,7 @@
                   <a:srgbClr val="FFFFFF"/>
                 </a:solidFill>
               </a:rPr>
-              <a:t>위치 정밀도</a:t>
+              <a:t>온습도 분리</a:t>
             </a:r>
             <a:endParaRPr lang="en-US" sz="1200" dirty="0"/>
           </a:p>
@@ -9372,7 +9698,7 @@
                   <a:srgbClr val="222222"/>
                 </a:solidFill>
               </a:rPr>
-              <a:t>IP → 위도/경도 직접 활용</a:t>
+              <a:t>온도:</a:t>
             </a:r>
             <a:endParaRPr lang="en-US" sz="1100" dirty="0"/>
           </a:p>
@@ -9386,7 +9712,35 @@
                   <a:srgbClr val="222222"/>
                 </a:solidFill>
               </a:rPr>
-              <a:t>기상청 격자 변환 불필요</a:t>
+              <a:t>wttr.in 외부값</a:t>
+            </a:r>
+            <a:endParaRPr lang="en-US" sz="1100" dirty="0"/>
+          </a:p>
+          <a:p>
+            <a:pPr indent="0" marL="0">
+              <a:buNone/>
+            </a:pPr>
+            <a:r>
+              <a:rPr lang="en-US" sz="1100" dirty="0">
+                <a:solidFill>
+                  <a:srgbClr val="222222"/>
+                </a:solidFill>
+              </a:rPr>
+              <a:t>습도:</a:t>
+            </a:r>
+            <a:endParaRPr lang="en-US" sz="1100" dirty="0"/>
+          </a:p>
+          <a:p>
+            <a:pPr indent="0" marL="0">
+              <a:buNone/>
+            </a:pPr>
+            <a:r>
+              <a:rPr lang="en-US" sz="1100" dirty="0">
+                <a:solidFill>
+                  <a:srgbClr val="222222"/>
+                </a:solidFill>
+              </a:rPr>
+              <a:t>DHT11 실내 센서</a:t>
             </a:r>
             <a:endParaRPr lang="en-US" sz="1100" dirty="0"/>
           </a:p>

</xml_diff>